<commit_message>
Slides: sd-04-046 PPTX re-export, one line within 10 words
Co-Authored-By: Claude Opus 5.5 <noreply@anthropic.com>
Claude-Session: https://claude.ai/code/session_01JWtUsCyy9ESaq4agyTKnFb
</commit_message>
<xml_diff>
--- a/system-design-101/vi/lessons/sd-04-046/slides/sd-04-046.pptx
+++ b/system-design-101/vi/lessons/sd-04-046/slides/sd-04-046.pptx
@@ -7161,95 +7161,73 @@
               <a:buNone/>
             </a:pPr>
             <a:r>
+              <a:rPr lang="en-US" sz="1950" dirty="0" spc="-41" kern="0">
+                <a:solidFill>
+                  <a:srgbClr val="9AA0B5"/>
+                </a:solidFill>
+                <a:latin typeface="Be Vietnam Pro" pitchFamily="34" charset="0"/>
+                <a:ea typeface="Be Vietnam Pro" pitchFamily="34" charset="-122"/>
+                <a:cs typeface="Be Vietnam Pro" pitchFamily="34" charset="-120"/>
+              </a:rPr>
+              <a:t>Tầng</a:t>
+            </a:r>
+            <a:r>
+              <a:rPr lang="en-US" sz="1950" dirty="0" spc="0" kern="0">
+                <a:solidFill>
+                  <a:srgbClr val="9AA0B5"/>
+                </a:solidFill>
+                <a:latin typeface="Be Vietnam Pro" pitchFamily="34" charset="0"/>
+                <a:ea typeface="Be Vietnam Pro" pitchFamily="34" charset="-122"/>
+                <a:cs typeface="Be Vietnam Pro" pitchFamily="34" charset="-120"/>
+              </a:rPr>
+              <a:t> 1</a:t>
+            </a:r>
+            <a:r>
+              <a:rPr lang="en-US" sz="1950" dirty="0" spc="-4" kern="0">
+                <a:solidFill>
+                  <a:srgbClr val="9AA0B5"/>
+                </a:solidFill>
+                <a:latin typeface="Be Vietnam Pro" pitchFamily="34" charset="0"/>
+                <a:ea typeface="Be Vietnam Pro" pitchFamily="34" charset="-122"/>
+                <a:cs typeface="Be Vietnam Pro" pitchFamily="34" charset="-120"/>
+              </a:rPr>
+              <a:t> báo</a:t>
+            </a:r>
+            <a:r>
+              <a:rPr lang="en-US" sz="1950" dirty="0" spc="11" kern="0">
+                <a:solidFill>
+                  <a:srgbClr val="9AA0B5"/>
+                </a:solidFill>
+                <a:latin typeface="Be Vietnam Pro" pitchFamily="34" charset="0"/>
+                <a:ea typeface="Be Vietnam Pro" pitchFamily="34" charset="-122"/>
+                <a:cs typeface="Be Vietnam Pro" pitchFamily="34" charset="-120"/>
+              </a:rPr>
+              <a:t> 48</a:t>
+            </a:r>
+            <a:r>
+              <a:rPr lang="en-US" sz="1950" dirty="0" spc="1" kern="0">
+                <a:solidFill>
+                  <a:srgbClr val="9AA0B5"/>
+                </a:solidFill>
+                <a:latin typeface="Be Vietnam Pro" pitchFamily="34" charset="0"/>
+                <a:ea typeface="Be Vietnam Pro" pitchFamily="34" charset="-122"/>
+                <a:cs typeface="Be Vietnam Pro" pitchFamily="34" charset="-120"/>
+              </a:rPr>
+              <a:t> KiB;</a:t>
+            </a:r>
+            <a:r>
+              <a:rPr lang="en-US" sz="1950" dirty="0" spc="-7" kern="0">
+                <a:solidFill>
+                  <a:srgbClr val="9AA0B5"/>
+                </a:solidFill>
+                <a:latin typeface="Be Vietnam Pro" pitchFamily="34" charset="0"/>
+                <a:ea typeface="Be Vietnam Pro" pitchFamily="34" charset="-122"/>
+                <a:cs typeface="Be Vietnam Pro" pitchFamily="34" charset="-120"/>
+              </a:rPr>
+              <a:t> tầng</a:t>
+            </a:r>
+            <a:r>
               <a:rPr lang="en-US" sz="1950" dirty="0" spc="-1" kern="0">
-                <a:solidFill>
-                  <a:srgbClr val="9AA0B5"/>
-                </a:solidFill>
-                <a:latin typeface="Be Vietnam Pro" pitchFamily="34" charset="0"/>
-                <a:ea typeface="Be Vietnam Pro" pitchFamily="34" charset="-122"/>
-                <a:cs typeface="Be Vietnam Pro" pitchFamily="34" charset="-120"/>
-              </a:rPr>
-              <a:t>Bộ</a:t>
-            </a:r>
-            <a:r>
-              <a:rPr lang="en-US" sz="1950" dirty="0" spc="11" kern="0">
-                <a:solidFill>
-                  <a:srgbClr val="9AA0B5"/>
-                </a:solidFill>
-                <a:latin typeface="Be Vietnam Pro" pitchFamily="34" charset="0"/>
-                <a:ea typeface="Be Vietnam Pro" pitchFamily="34" charset="-122"/>
-                <a:cs typeface="Be Vietnam Pro" pitchFamily="34" charset="-120"/>
-              </a:rPr>
-              <a:t> đệm</a:t>
-            </a:r>
-            <a:r>
-              <a:rPr lang="en-US" sz="1950" dirty="0" spc="-7" kern="0">
-                <a:solidFill>
-                  <a:srgbClr val="9AA0B5"/>
-                </a:solidFill>
-                <a:latin typeface="Be Vietnam Pro" pitchFamily="34" charset="0"/>
-                <a:ea typeface="Be Vietnam Pro" pitchFamily="34" charset="-122"/>
-                <a:cs typeface="Be Vietnam Pro" pitchFamily="34" charset="-120"/>
-              </a:rPr>
-              <a:t> tầng</a:t>
-            </a:r>
-            <a:r>
-              <a:rPr lang="en-US" sz="1950" dirty="0" spc="-1" kern="0">
-                <a:solidFill>
-                  <a:srgbClr val="9AA0B5"/>
-                </a:solidFill>
-                <a:latin typeface="Be Vietnam Pro" pitchFamily="34" charset="0"/>
-                <a:ea typeface="Be Vietnam Pro" pitchFamily="34" charset="-122"/>
-                <a:cs typeface="Be Vietnam Pro" pitchFamily="34" charset="-120"/>
-              </a:rPr>
-              <a:t> 1</a:t>
-            </a:r>
-            <a:r>
-              <a:rPr lang="en-US" sz="1950" dirty="0" spc="-3" kern="0">
-                <a:solidFill>
-                  <a:srgbClr val="9AA0B5"/>
-                </a:solidFill>
-                <a:latin typeface="Be Vietnam Pro" pitchFamily="34" charset="0"/>
-                <a:ea typeface="Be Vietnam Pro" pitchFamily="34" charset="-122"/>
-                <a:cs typeface="Be Vietnam Pro" pitchFamily="34" charset="-120"/>
-              </a:rPr>
-              <a:t> báo</a:t>
-            </a:r>
-            <a:r>
-              <a:rPr lang="en-US" sz="1950" dirty="0" spc="11" kern="0">
-                <a:solidFill>
-                  <a:srgbClr val="9AA0B5"/>
-                </a:solidFill>
-                <a:latin typeface="Be Vietnam Pro" pitchFamily="34" charset="0"/>
-                <a:ea typeface="Be Vietnam Pro" pitchFamily="34" charset="-122"/>
-                <a:cs typeface="Be Vietnam Pro" pitchFamily="34" charset="-120"/>
-              </a:rPr>
-              <a:t> 48</a:t>
-            </a:r>
-            <a:r>
-              <a:rPr lang="en-US" sz="1950" dirty="0" spc="1" kern="0">
-                <a:solidFill>
-                  <a:srgbClr val="9AA0B5"/>
-                </a:solidFill>
-                <a:latin typeface="Be Vietnam Pro" pitchFamily="34" charset="0"/>
-                <a:ea typeface="Be Vietnam Pro" pitchFamily="34" charset="-122"/>
-                <a:cs typeface="Be Vietnam Pro" pitchFamily="34" charset="-120"/>
-              </a:rPr>
-              <a:t> KiB;</a:t>
-            </a:r>
-            <a:r>
-              <a:rPr lang="en-US" sz="1950" dirty="0" spc="-8" kern="0">
-                <a:solidFill>
-                  <a:srgbClr val="9AA0B5"/>
-                </a:solidFill>
-                <a:latin typeface="Be Vietnam Pro" pitchFamily="34" charset="0"/>
-                <a:ea typeface="Be Vietnam Pro" pitchFamily="34" charset="-122"/>
-                <a:cs typeface="Be Vietnam Pro" pitchFamily="34" charset="-120"/>
-              </a:rPr>
-              <a:t> tầng</a:t>
-            </a:r>
-            <a:r>
-              <a:rPr lang="en-US" sz="1950" dirty="0" spc="0" kern="0">
                 <a:solidFill>
                   <a:srgbClr val="9AA0B5"/>
                 </a:solidFill>

</xml_diff>